<commit_message>
Update binary resources and remove temporary PowerPoint file
- Updated the aidlc.png image to a new version.
- Deleted the temporary PowerPoint file ~\$Xianix.ai.PPT.pptx to clean up resources.
- Updated the main Xianix.ai.PPT.pptx presentation file to a new version.
</commit_message>
<xml_diff>
--- a/resources/Xianix.ai.PPT.pptx
+++ b/resources/Xianix.ai.PPT.pptx
@@ -3642,6 +3642,61 @@
           <a:chExt cx="0" cy="0"/>
         </a:xfrm>
       </p:grpSpPr>
+      <p:sp>
+        <p:nvSpPr>
+          <p:cNvPr id="34" name="Striped Right Arrow 33">
+            <a:extLst>
+              <a:ext uri="{FF2B5EF4-FFF2-40B4-BE49-F238E27FC236}">
+                <a16:creationId xmlns:a16="http://schemas.microsoft.com/office/drawing/2014/main" id="{59A8BB6C-92AE-26EC-CE4B-9E709BD353D8}"/>
+              </a:ext>
+            </a:extLst>
+          </p:cNvPr>
+          <p:cNvSpPr/>
+          <p:nvPr/>
+        </p:nvSpPr>
+        <p:spPr>
+          <a:xfrm>
+            <a:off x="2637586" y="5683544"/>
+            <a:ext cx="1724204" cy="672662"/>
+          </a:xfrm>
+          <a:prstGeom prst="stripedRightArrow">
+            <a:avLst/>
+          </a:prstGeom>
+          <a:solidFill>
+            <a:schemeClr val="tx1">
+              <a:lumMod val="50000"/>
+              <a:lumOff val="50000"/>
+            </a:schemeClr>
+          </a:solidFill>
+          <a:ln>
+            <a:noFill/>
+          </a:ln>
+        </p:spPr>
+        <p:style>
+          <a:lnRef idx="2">
+            <a:schemeClr val="accent1">
+              <a:shade val="15000"/>
+            </a:schemeClr>
+          </a:lnRef>
+          <a:fillRef idx="1">
+            <a:schemeClr val="accent1"/>
+          </a:fillRef>
+          <a:effectRef idx="0">
+            <a:schemeClr val="accent1"/>
+          </a:effectRef>
+          <a:fontRef idx="minor">
+            <a:schemeClr val="lt1"/>
+          </a:fontRef>
+        </p:style>
+        <p:txBody>
+          <a:bodyPr rtlCol="0" anchor="ctr"/>
+          <a:lstStyle/>
+          <a:p>
+            <a:pPr algn="ctr"/>
+            <a:endParaRPr lang="en-US"/>
+          </a:p>
+        </p:txBody>
+      </p:sp>
       <p:pic>
         <p:nvPicPr>
           <p:cNvPr id="5" name="Picture 4">
@@ -3664,7 +3719,7 @@
         </p:blipFill>
         <p:spPr>
           <a:xfrm>
-            <a:off x="2494126" y="2949537"/>
+            <a:off x="2630759" y="2413510"/>
             <a:ext cx="1052184" cy="1052184"/>
           </a:xfrm>
           <a:prstGeom prst="rect">
@@ -3694,7 +3749,7 @@
         </p:blipFill>
         <p:spPr>
           <a:xfrm>
-            <a:off x="3447440" y="2275643"/>
+            <a:off x="3584073" y="1739616"/>
             <a:ext cx="2104356" cy="2408663"/>
           </a:xfrm>
           <a:prstGeom prst="rect">
@@ -3724,7 +3779,7 @@
         </p:blipFill>
         <p:spPr>
           <a:xfrm>
-            <a:off x="5362894" y="2897219"/>
+            <a:off x="5499527" y="2361192"/>
             <a:ext cx="1145892" cy="1145892"/>
           </a:xfrm>
           <a:prstGeom prst="rect">
@@ -3754,7 +3809,7 @@
         </p:blipFill>
         <p:spPr>
           <a:xfrm>
-            <a:off x="7313555" y="1417565"/>
+            <a:off x="7450188" y="881538"/>
             <a:ext cx="562827" cy="752141"/>
           </a:xfrm>
           <a:prstGeom prst="rect">
@@ -3784,7 +3839,7 @@
         </p:blipFill>
         <p:spPr>
           <a:xfrm>
-            <a:off x="9278028" y="2949537"/>
+            <a:off x="9414661" y="2413510"/>
             <a:ext cx="562827" cy="752141"/>
           </a:xfrm>
           <a:prstGeom prst="rect">
@@ -3814,7 +3869,7 @@
         </p:blipFill>
         <p:spPr>
           <a:xfrm>
-            <a:off x="8679579" y="1934734"/>
+            <a:off x="8816212" y="1398707"/>
             <a:ext cx="566420" cy="690003"/>
           </a:xfrm>
           <a:prstGeom prst="rect">
@@ -3844,7 +3899,7 @@
         </p:blipFill>
         <p:spPr>
           <a:xfrm>
-            <a:off x="8986752" y="4021371"/>
+            <a:off x="9123385" y="3485344"/>
             <a:ext cx="566421" cy="690003"/>
           </a:xfrm>
           <a:prstGeom prst="rect">
@@ -3874,7 +3929,7 @@
         </p:blipFill>
         <p:spPr>
           <a:xfrm>
-            <a:off x="7576228" y="4694740"/>
+            <a:off x="7712861" y="4158713"/>
             <a:ext cx="707970" cy="707970"/>
           </a:xfrm>
           <a:prstGeom prst="rect">
@@ -3904,7 +3959,7 @@
         </p:blipFill>
         <p:spPr>
           <a:xfrm>
-            <a:off x="6227377" y="1843082"/>
+            <a:off x="6364010" y="1307055"/>
             <a:ext cx="3187630" cy="3239377"/>
           </a:xfrm>
           <a:prstGeom prst="rect">
@@ -3926,8 +3981,8 @@
         </p:nvSpPr>
         <p:spPr>
           <a:xfrm>
-            <a:off x="158982" y="3032828"/>
-            <a:ext cx="2196978" cy="738664"/>
+            <a:off x="1055912" y="2559862"/>
+            <a:ext cx="1678418" cy="738664"/>
           </a:xfrm>
           <a:prstGeom prst="rect">
             <a:avLst/>
@@ -3940,7 +3995,6 @@
           </a:bodyPr>
           <a:lstStyle/>
           <a:p>
-            <a:pPr algn="r"/>
             <a:r>
               <a:rPr lang="en-US" sz="1400" dirty="0">
                 <a:solidFill>
@@ -3954,7 +4008,6 @@
             </a:r>
           </a:p>
           <a:p>
-            <a:pPr algn="r"/>
             <a:r>
               <a:rPr lang="en-US" sz="1400" dirty="0">
                 <a:solidFill>
@@ -3968,7 +4021,6 @@
             </a:r>
           </a:p>
           <a:p>
-            <a:pPr algn="r"/>
             <a:r>
               <a:rPr lang="en-US" sz="1400" dirty="0">
                 <a:solidFill>
@@ -3997,7 +4049,7 @@
         </p:nvSpPr>
         <p:spPr>
           <a:xfrm>
-            <a:off x="1872294" y="4272258"/>
+            <a:off x="2008927" y="3736231"/>
             <a:ext cx="2196978" cy="553998"/>
           </a:xfrm>
           <a:prstGeom prst="rect">
@@ -4054,7 +4106,7 @@
         </p:nvSpPr>
         <p:spPr>
           <a:xfrm>
-            <a:off x="3546310" y="2872561"/>
+            <a:off x="3682943" y="2336534"/>
             <a:ext cx="1816584" cy="1384995"/>
           </a:xfrm>
           <a:prstGeom prst="rect">
@@ -4146,7 +4198,7 @@
         </p:nvSpPr>
         <p:spPr>
           <a:xfrm>
-            <a:off x="9191116" y="2014033"/>
+            <a:off x="9327749" y="1478006"/>
             <a:ext cx="1250979" cy="523220"/>
           </a:xfrm>
           <a:prstGeom prst="rect">
@@ -4203,7 +4255,7 @@
         </p:nvSpPr>
         <p:spPr>
           <a:xfrm>
-            <a:off x="6890930" y="3093438"/>
+            <a:off x="7027563" y="2557411"/>
             <a:ext cx="1816584" cy="738664"/>
           </a:xfrm>
           <a:prstGeom prst="rect">
@@ -4271,7 +4323,7 @@
         </p:nvSpPr>
         <p:spPr>
           <a:xfrm>
-            <a:off x="9816605" y="3140550"/>
+            <a:off x="9953238" y="2604523"/>
             <a:ext cx="1100657" cy="523220"/>
           </a:xfrm>
           <a:prstGeom prst="rect">
@@ -4328,7 +4380,7 @@
         </p:nvSpPr>
         <p:spPr>
           <a:xfrm>
-            <a:off x="9687402" y="4145285"/>
+            <a:off x="9824035" y="3609258"/>
             <a:ext cx="1100657" cy="523220"/>
           </a:xfrm>
           <a:prstGeom prst="rect">
@@ -4385,8 +4437,8 @@
         </p:nvSpPr>
         <p:spPr>
           <a:xfrm>
-            <a:off x="8284198" y="5098312"/>
-            <a:ext cx="1403204" cy="523220"/>
+            <a:off x="8420831" y="4562285"/>
+            <a:ext cx="961801" cy="307777"/>
           </a:xfrm>
           <a:prstGeom prst="rect">
             <a:avLst/>
@@ -4409,7 +4461,50 @@
                 <a:ea typeface="Inter SemiBold" panose="02000503000000020004" pitchFamily="2" charset="0"/>
                 <a:cs typeface="Inter SemiBold" panose="02000503000000020004" pitchFamily="2" charset="0"/>
               </a:rPr>
-              <a:t>Documentation</a:t>
+              <a:t>…</a:t>
+            </a:r>
+          </a:p>
+        </p:txBody>
+      </p:sp>
+      <p:sp>
+        <p:nvSpPr>
+          <p:cNvPr id="3" name="TextBox 2">
+            <a:extLst>
+              <a:ext uri="{FF2B5EF4-FFF2-40B4-BE49-F238E27FC236}">
+                <a16:creationId xmlns:a16="http://schemas.microsoft.com/office/drawing/2014/main" id="{C26F9823-3963-1B80-92BD-90AA1AA85472}"/>
+              </a:ext>
+            </a:extLst>
+          </p:cNvPr>
+          <p:cNvSpPr txBox="1"/>
+          <p:nvPr/>
+        </p:nvSpPr>
+        <p:spPr>
+          <a:xfrm>
+            <a:off x="7957825" y="583701"/>
+            <a:ext cx="1403204" cy="523220"/>
+          </a:xfrm>
+          <a:prstGeom prst="rect">
+            <a:avLst/>
+          </a:prstGeom>
+          <a:noFill/>
+        </p:spPr>
+        <p:txBody>
+          <a:bodyPr wrap="square" rtlCol="0">
+            <a:spAutoFit/>
+          </a:bodyPr>
+          <a:lstStyle/>
+          <a:p>
+            <a:pPr algn="ctr"/>
+            <a:r>
+              <a:rPr lang="en-US" sz="1400" dirty="0">
+                <a:solidFill>
+                  <a:srgbClr val="A2B472"/>
+                </a:solidFill>
+                <a:latin typeface="Inter SemiBold" panose="02000503000000020004" pitchFamily="2" charset="0"/>
+                <a:ea typeface="Inter SemiBold" panose="02000503000000020004" pitchFamily="2" charset="0"/>
+                <a:cs typeface="Inter SemiBold" panose="02000503000000020004" pitchFamily="2" charset="0"/>
+              </a:rPr>
+              <a:t>Requirement</a:t>
             </a:r>
           </a:p>
           <a:p>
@@ -4430,10 +4525,10 @@
       </p:sp>
       <p:sp>
         <p:nvSpPr>
-          <p:cNvPr id="3" name="TextBox 2">
+          <p:cNvPr id="13" name="TextBox 12">
             <a:extLst>
               <a:ext uri="{FF2B5EF4-FFF2-40B4-BE49-F238E27FC236}">
-                <a16:creationId xmlns:a16="http://schemas.microsoft.com/office/drawing/2014/main" id="{C26F9823-3963-1B80-92BD-90AA1AA85472}"/>
+                <a16:creationId xmlns:a16="http://schemas.microsoft.com/office/drawing/2014/main" id="{8584E2BA-9ACC-A587-A318-1D254A9FFA38}"/>
               </a:ext>
             </a:extLst>
           </p:cNvPr>
@@ -4442,8 +4537,8 @@
         </p:nvSpPr>
         <p:spPr>
           <a:xfrm>
-            <a:off x="7821192" y="1119728"/>
-            <a:ext cx="1403204" cy="523220"/>
+            <a:off x="2795241" y="5863404"/>
+            <a:ext cx="1101306" cy="307777"/>
           </a:xfrm>
           <a:prstGeom prst="rect">
             <a:avLst/>
@@ -4460,27 +4555,307 @@
             <a:r>
               <a:rPr lang="en-US" sz="1400" dirty="0">
                 <a:solidFill>
-                  <a:srgbClr val="A2B472"/>
+                  <a:schemeClr val="bg1"/>
                 </a:solidFill>
-                <a:latin typeface="Inter SemiBold" panose="02000503000000020004" pitchFamily="2" charset="0"/>
-                <a:ea typeface="Inter SemiBold" panose="02000503000000020004" pitchFamily="2" charset="0"/>
-                <a:cs typeface="Inter SemiBold" panose="02000503000000020004" pitchFamily="2" charset="0"/>
+                <a:latin typeface="Inter Medium" panose="02000503000000020004" pitchFamily="2" charset="0"/>
+                <a:ea typeface="Inter Medium" panose="02000503000000020004" pitchFamily="2" charset="0"/>
+                <a:cs typeface="Inter Medium" panose="02000503000000020004" pitchFamily="2" charset="0"/>
               </a:rPr>
-              <a:t>Requirement</a:t>
-            </a:r>
-          </a:p>
+              <a:t>Inception</a:t>
+            </a:r>
+          </a:p>
+        </p:txBody>
+      </p:sp>
+      <p:sp>
+        <p:nvSpPr>
+          <p:cNvPr id="35" name="Striped Right Arrow 34">
+            <a:extLst>
+              <a:ext uri="{FF2B5EF4-FFF2-40B4-BE49-F238E27FC236}">
+                <a16:creationId xmlns:a16="http://schemas.microsoft.com/office/drawing/2014/main" id="{97B8174C-279C-1B2B-0DAB-04579AED8D6D}"/>
+              </a:ext>
+            </a:extLst>
+          </p:cNvPr>
+          <p:cNvSpPr/>
+          <p:nvPr/>
+        </p:nvSpPr>
+        <p:spPr>
+          <a:xfrm>
+            <a:off x="4639806" y="5689297"/>
+            <a:ext cx="1724204" cy="672662"/>
+          </a:xfrm>
+          <a:prstGeom prst="stripedRightArrow">
+            <a:avLst/>
+          </a:prstGeom>
+          <a:solidFill>
+            <a:schemeClr val="tx1">
+              <a:lumMod val="50000"/>
+              <a:lumOff val="50000"/>
+            </a:schemeClr>
+          </a:solidFill>
+          <a:ln>
+            <a:noFill/>
+          </a:ln>
+        </p:spPr>
+        <p:style>
+          <a:lnRef idx="2">
+            <a:schemeClr val="accent1">
+              <a:shade val="15000"/>
+            </a:schemeClr>
+          </a:lnRef>
+          <a:fillRef idx="1">
+            <a:schemeClr val="accent1"/>
+          </a:fillRef>
+          <a:effectRef idx="0">
+            <a:schemeClr val="accent1"/>
+          </a:effectRef>
+          <a:fontRef idx="minor">
+            <a:schemeClr val="lt1"/>
+          </a:fontRef>
+        </p:style>
+        <p:txBody>
+          <a:bodyPr rtlCol="0" anchor="ctr"/>
+          <a:lstStyle/>
+          <a:p>
+            <a:pPr algn="ctr"/>
+            <a:endParaRPr lang="en-US"/>
+          </a:p>
+        </p:txBody>
+      </p:sp>
+      <p:sp>
+        <p:nvSpPr>
+          <p:cNvPr id="36" name="TextBox 35">
+            <a:extLst>
+              <a:ext uri="{FF2B5EF4-FFF2-40B4-BE49-F238E27FC236}">
+                <a16:creationId xmlns:a16="http://schemas.microsoft.com/office/drawing/2014/main" id="{B4D4BEE0-8C49-CC38-A5D3-61356BB14014}"/>
+              </a:ext>
+            </a:extLst>
+          </p:cNvPr>
+          <p:cNvSpPr txBox="1"/>
+          <p:nvPr/>
+        </p:nvSpPr>
+        <p:spPr>
+          <a:xfrm>
+            <a:off x="4797460" y="5869157"/>
+            <a:ext cx="1382375" cy="307777"/>
+          </a:xfrm>
+          <a:prstGeom prst="rect">
+            <a:avLst/>
+          </a:prstGeom>
+          <a:noFill/>
+        </p:spPr>
+        <p:txBody>
+          <a:bodyPr wrap="square" rtlCol="0">
+            <a:spAutoFit/>
+          </a:bodyPr>
+          <a:lstStyle/>
           <a:p>
             <a:pPr algn="ctr"/>
             <a:r>
               <a:rPr lang="en-US" sz="1400" dirty="0">
                 <a:solidFill>
-                  <a:srgbClr val="A2B472"/>
+                  <a:schemeClr val="bg1"/>
                 </a:solidFill>
-                <a:latin typeface="Inter SemiBold" panose="02000503000000020004" pitchFamily="2" charset="0"/>
-                <a:ea typeface="Inter SemiBold" panose="02000503000000020004" pitchFamily="2" charset="0"/>
-                <a:cs typeface="Inter SemiBold" panose="02000503000000020004" pitchFamily="2" charset="0"/>
+                <a:latin typeface="Inter Medium" panose="02000503000000020004" pitchFamily="2" charset="0"/>
+                <a:ea typeface="Inter Medium" panose="02000503000000020004" pitchFamily="2" charset="0"/>
+                <a:cs typeface="Inter Medium" panose="02000503000000020004" pitchFamily="2" charset="0"/>
               </a:rPr>
-              <a:t>Agents</a:t>
+              <a:t>Construction</a:t>
+            </a:r>
+          </a:p>
+        </p:txBody>
+      </p:sp>
+      <p:sp>
+        <p:nvSpPr>
+          <p:cNvPr id="37" name="Striped Right Arrow 36">
+            <a:extLst>
+              <a:ext uri="{FF2B5EF4-FFF2-40B4-BE49-F238E27FC236}">
+                <a16:creationId xmlns:a16="http://schemas.microsoft.com/office/drawing/2014/main" id="{1407B600-6FB5-F61E-501A-5179E62E9748}"/>
+              </a:ext>
+            </a:extLst>
+          </p:cNvPr>
+          <p:cNvSpPr/>
+          <p:nvPr/>
+        </p:nvSpPr>
+        <p:spPr>
+          <a:xfrm>
+            <a:off x="6649441" y="5683544"/>
+            <a:ext cx="1724204" cy="672662"/>
+          </a:xfrm>
+          <a:prstGeom prst="stripedRightArrow">
+            <a:avLst/>
+          </a:prstGeom>
+          <a:solidFill>
+            <a:schemeClr val="tx1">
+              <a:lumMod val="50000"/>
+              <a:lumOff val="50000"/>
+            </a:schemeClr>
+          </a:solidFill>
+          <a:ln>
+            <a:noFill/>
+          </a:ln>
+        </p:spPr>
+        <p:style>
+          <a:lnRef idx="2">
+            <a:schemeClr val="accent1">
+              <a:shade val="15000"/>
+            </a:schemeClr>
+          </a:lnRef>
+          <a:fillRef idx="1">
+            <a:schemeClr val="accent1"/>
+          </a:fillRef>
+          <a:effectRef idx="0">
+            <a:schemeClr val="accent1"/>
+          </a:effectRef>
+          <a:fontRef idx="minor">
+            <a:schemeClr val="lt1"/>
+          </a:fontRef>
+        </p:style>
+        <p:txBody>
+          <a:bodyPr rtlCol="0" anchor="ctr"/>
+          <a:lstStyle/>
+          <a:p>
+            <a:pPr algn="ctr"/>
+            <a:endParaRPr lang="en-US"/>
+          </a:p>
+        </p:txBody>
+      </p:sp>
+      <p:sp>
+        <p:nvSpPr>
+          <p:cNvPr id="38" name="TextBox 37">
+            <a:extLst>
+              <a:ext uri="{FF2B5EF4-FFF2-40B4-BE49-F238E27FC236}">
+                <a16:creationId xmlns:a16="http://schemas.microsoft.com/office/drawing/2014/main" id="{281CC698-CB96-8EE3-A4F3-9C5AC80EF171}"/>
+              </a:ext>
+            </a:extLst>
+          </p:cNvPr>
+          <p:cNvSpPr txBox="1"/>
+          <p:nvPr/>
+        </p:nvSpPr>
+        <p:spPr>
+          <a:xfrm>
+            <a:off x="6807096" y="5863404"/>
+            <a:ext cx="1101306" cy="307777"/>
+          </a:xfrm>
+          <a:prstGeom prst="rect">
+            <a:avLst/>
+          </a:prstGeom>
+          <a:noFill/>
+        </p:spPr>
+        <p:txBody>
+          <a:bodyPr wrap="square" rtlCol="0">
+            <a:spAutoFit/>
+          </a:bodyPr>
+          <a:lstStyle/>
+          <a:p>
+            <a:pPr algn="ctr"/>
+            <a:r>
+              <a:rPr lang="en-US" sz="1400" dirty="0">
+                <a:solidFill>
+                  <a:schemeClr val="bg1"/>
+                </a:solidFill>
+                <a:latin typeface="Inter Medium" panose="02000503000000020004" pitchFamily="2" charset="0"/>
+                <a:ea typeface="Inter Medium" panose="02000503000000020004" pitchFamily="2" charset="0"/>
+                <a:cs typeface="Inter Medium" panose="02000503000000020004" pitchFamily="2" charset="0"/>
+              </a:rPr>
+              <a:t>Operation</a:t>
+            </a:r>
+          </a:p>
+        </p:txBody>
+      </p:sp>
+      <p:sp>
+        <p:nvSpPr>
+          <p:cNvPr id="39" name="Striped Right Arrow 38">
+            <a:extLst>
+              <a:ext uri="{FF2B5EF4-FFF2-40B4-BE49-F238E27FC236}">
+                <a16:creationId xmlns:a16="http://schemas.microsoft.com/office/drawing/2014/main" id="{93317102-5485-B78E-3CBD-F5C535750FFA}"/>
+              </a:ext>
+            </a:extLst>
+          </p:cNvPr>
+          <p:cNvSpPr/>
+          <p:nvPr/>
+        </p:nvSpPr>
+        <p:spPr>
+          <a:xfrm>
+            <a:off x="8651661" y="5683544"/>
+            <a:ext cx="1724204" cy="672662"/>
+          </a:xfrm>
+          <a:prstGeom prst="stripedRightArrow">
+            <a:avLst/>
+          </a:prstGeom>
+          <a:solidFill>
+            <a:schemeClr val="tx1">
+              <a:lumMod val="50000"/>
+              <a:lumOff val="50000"/>
+            </a:schemeClr>
+          </a:solidFill>
+          <a:ln>
+            <a:noFill/>
+          </a:ln>
+        </p:spPr>
+        <p:style>
+          <a:lnRef idx="2">
+            <a:schemeClr val="accent1">
+              <a:shade val="15000"/>
+            </a:schemeClr>
+          </a:lnRef>
+          <a:fillRef idx="1">
+            <a:schemeClr val="accent1"/>
+          </a:fillRef>
+          <a:effectRef idx="0">
+            <a:schemeClr val="accent1"/>
+          </a:effectRef>
+          <a:fontRef idx="minor">
+            <a:schemeClr val="lt1"/>
+          </a:fontRef>
+        </p:style>
+        <p:txBody>
+          <a:bodyPr rtlCol="0" anchor="ctr"/>
+          <a:lstStyle/>
+          <a:p>
+            <a:pPr algn="ctr"/>
+            <a:endParaRPr lang="en-US"/>
+          </a:p>
+        </p:txBody>
+      </p:sp>
+      <p:sp>
+        <p:nvSpPr>
+          <p:cNvPr id="40" name="TextBox 39">
+            <a:extLst>
+              <a:ext uri="{FF2B5EF4-FFF2-40B4-BE49-F238E27FC236}">
+                <a16:creationId xmlns:a16="http://schemas.microsoft.com/office/drawing/2014/main" id="{17B7E44F-D644-2035-19F5-530AD00E6B81}"/>
+              </a:ext>
+            </a:extLst>
+          </p:cNvPr>
+          <p:cNvSpPr txBox="1"/>
+          <p:nvPr/>
+        </p:nvSpPr>
+        <p:spPr>
+          <a:xfrm>
+            <a:off x="8809316" y="5863404"/>
+            <a:ext cx="1101306" cy="307777"/>
+          </a:xfrm>
+          <a:prstGeom prst="rect">
+            <a:avLst/>
+          </a:prstGeom>
+          <a:noFill/>
+        </p:spPr>
+        <p:txBody>
+          <a:bodyPr wrap="square" rtlCol="0">
+            <a:spAutoFit/>
+          </a:bodyPr>
+          <a:lstStyle/>
+          <a:p>
+            <a:pPr algn="ctr"/>
+            <a:r>
+              <a:rPr lang="en-US" sz="1400" dirty="0">
+                <a:solidFill>
+                  <a:schemeClr val="bg1"/>
+                </a:solidFill>
+                <a:latin typeface="Inter Medium" panose="02000503000000020004" pitchFamily="2" charset="0"/>
+                <a:ea typeface="Inter Medium" panose="02000503000000020004" pitchFamily="2" charset="0"/>
+                <a:cs typeface="Inter Medium" panose="02000503000000020004" pitchFamily="2" charset="0"/>
+              </a:rPr>
+              <a:t>Adaption</a:t>
             </a:r>
           </a:p>
         </p:txBody>

</xml_diff>